<commit_message>
docs(presentation): update author details in presentation slides
</commit_message>
<xml_diff>
--- a/presentation_slides.pptx
+++ b/presentation_slides.pptx
@@ -5,22 +5,22 @@
     <p:sldMasterId id="2147483648" r:id="rId1"/>
   </p:sldMasterIdLst>
   <p:sldIdLst>
-    <p:sldId id="256" r:id="rId7"/>
-    <p:sldId id="257" r:id="rId8"/>
-    <p:sldId id="258" r:id="rId9"/>
-    <p:sldId id="259" r:id="rId10"/>
-    <p:sldId id="260" r:id="rId11"/>
-    <p:sldId id="261" r:id="rId12"/>
-    <p:sldId id="262" r:id="rId13"/>
-    <p:sldId id="263" r:id="rId14"/>
-    <p:sldId id="264" r:id="rId15"/>
-    <p:sldId id="265" r:id="rId16"/>
-    <p:sldId id="266" r:id="rId17"/>
-    <p:sldId id="267" r:id="rId18"/>
-    <p:sldId id="268" r:id="rId19"/>
-    <p:sldId id="269" r:id="rId20"/>
+    <p:sldId id="256" r:id="rId2"/>
+    <p:sldId id="257" r:id="rId3"/>
+    <p:sldId id="258" r:id="rId4"/>
+    <p:sldId id="259" r:id="rId5"/>
+    <p:sldId id="260" r:id="rId6"/>
+    <p:sldId id="261" r:id="rId7"/>
+    <p:sldId id="262" r:id="rId8"/>
+    <p:sldId id="263" r:id="rId9"/>
+    <p:sldId id="264" r:id="rId10"/>
+    <p:sldId id="265" r:id="rId11"/>
+    <p:sldId id="266" r:id="rId12"/>
+    <p:sldId id="267" r:id="rId13"/>
+    <p:sldId id="268" r:id="rId14"/>
+    <p:sldId id="269" r:id="rId15"/>
   </p:sldIdLst>
-  <p:sldSz cx="12191695" cy="6858000" type="screen4x3"/>
+  <p:sldSz cx="12192000" cy="6858000"/>
   <p:notesSz cx="6858000" cy="9144000"/>
   <p:defaultTextStyle>
     <a:defPPr>
@@ -117,6 +117,22 @@
       </a:defRPr>
     </a:lvl9pPr>
   </p:defaultTextStyle>
+  <p:extLst>
+    <p:ext uri="{EFAFB233-063F-42B5-8137-9DF3F51BA10A}">
+      <p15:sldGuideLst xmlns:p15="http://schemas.microsoft.com/office/powerpoint/2012/main">
+        <p15:guide id="1" orient="horz" pos="2160">
+          <p15:clr>
+            <a:srgbClr val="A4A3A4"/>
+          </p15:clr>
+        </p15:guide>
+        <p15:guide id="2" pos="2880">
+          <p15:clr>
+            <a:srgbClr val="A4A3A4"/>
+          </p15:clr>
+        </p15:guide>
+      </p15:sldGuideLst>
+    </p:ext>
+  </p:extLst>
 </p:presentation>
 </file>
 
@@ -158,10 +174,9 @@
           <a:lstStyle/>
           <a:p>
             <a:r>
-              <a:rPr lang="en-US" smtClean="0"/>
+              <a:rPr lang="en-US"/>
               <a:t>Click to edit Master title style</a:t>
             </a:r>
-            <a:endParaRPr lang="en-US"/>
           </a:p>
         </p:txBody>
       </p:sp>
@@ -277,10 +292,9 @@
           </a:lstStyle>
           <a:p>
             <a:r>
-              <a:rPr lang="en-US" smtClean="0"/>
+              <a:rPr lang="en-US"/>
               <a:t>Click to edit Master subtitle style</a:t>
             </a:r>
-            <a:endParaRPr lang="en-US"/>
           </a:p>
         </p:txBody>
       </p:sp>
@@ -301,7 +315,7 @@
           <a:p>
             <a:fld id="{5BCAD085-E8A6-8845-BD4E-CB4CCA059FC4}" type="datetimeFigureOut">
               <a:rPr lang="en-US" smtClean="0"/>
-              <a:t>1/27/13</a:t>
+              <a:t>8/31/2026</a:t>
             </a:fld>
             <a:endParaRPr lang="en-US"/>
           </a:p>
@@ -395,10 +409,9 @@
           <a:lstStyle/>
           <a:p>
             <a:r>
-              <a:rPr lang="en-US" smtClean="0"/>
+              <a:rPr lang="en-US"/>
               <a:t>Click to edit Master title style</a:t>
             </a:r>
-            <a:endParaRPr lang="en-US"/>
           </a:p>
         </p:txBody>
       </p:sp>
@@ -419,38 +432,37 @@
           <a:p>
             <a:pPr lvl="0"/>
             <a:r>
-              <a:rPr lang="en-US" smtClean="0"/>
+              <a:rPr lang="en-US"/>
               <a:t>Click to edit Master text styles</a:t>
             </a:r>
           </a:p>
           <a:p>
             <a:pPr lvl="1"/>
             <a:r>
-              <a:rPr lang="en-US" smtClean="0"/>
+              <a:rPr lang="en-US"/>
               <a:t>Second level</a:t>
             </a:r>
           </a:p>
           <a:p>
             <a:pPr lvl="2"/>
             <a:r>
-              <a:rPr lang="en-US" smtClean="0"/>
+              <a:rPr lang="en-US"/>
               <a:t>Third level</a:t>
             </a:r>
           </a:p>
           <a:p>
             <a:pPr lvl="3"/>
             <a:r>
-              <a:rPr lang="en-US" smtClean="0"/>
+              <a:rPr lang="en-US"/>
               <a:t>Fourth level</a:t>
             </a:r>
           </a:p>
           <a:p>
             <a:pPr lvl="4"/>
             <a:r>
-              <a:rPr lang="en-US" smtClean="0"/>
+              <a:rPr lang="en-US"/>
               <a:t>Fifth level</a:t>
             </a:r>
-            <a:endParaRPr lang="en-US"/>
           </a:p>
         </p:txBody>
       </p:sp>
@@ -471,7 +483,7 @@
           <a:p>
             <a:fld id="{5BCAD085-E8A6-8845-BD4E-CB4CCA059FC4}" type="datetimeFigureOut">
               <a:rPr lang="en-US" smtClean="0"/>
-              <a:t>1/27/13</a:t>
+              <a:t>8/31/2026</a:t>
             </a:fld>
             <a:endParaRPr lang="en-US"/>
           </a:p>
@@ -570,10 +582,9 @@
           <a:lstStyle/>
           <a:p>
             <a:r>
-              <a:rPr lang="en-US" smtClean="0"/>
+              <a:rPr lang="en-US"/>
               <a:t>Click to edit Master title style</a:t>
             </a:r>
-            <a:endParaRPr lang="en-US"/>
           </a:p>
         </p:txBody>
       </p:sp>
@@ -599,38 +610,37 @@
           <a:p>
             <a:pPr lvl="0"/>
             <a:r>
-              <a:rPr lang="en-US" smtClean="0"/>
+              <a:rPr lang="en-US"/>
               <a:t>Click to edit Master text styles</a:t>
             </a:r>
           </a:p>
           <a:p>
             <a:pPr lvl="1"/>
             <a:r>
-              <a:rPr lang="en-US" smtClean="0"/>
+              <a:rPr lang="en-US"/>
               <a:t>Second level</a:t>
             </a:r>
           </a:p>
           <a:p>
             <a:pPr lvl="2"/>
             <a:r>
-              <a:rPr lang="en-US" smtClean="0"/>
+              <a:rPr lang="en-US"/>
               <a:t>Third level</a:t>
             </a:r>
           </a:p>
           <a:p>
             <a:pPr lvl="3"/>
             <a:r>
-              <a:rPr lang="en-US" smtClean="0"/>
+              <a:rPr lang="en-US"/>
               <a:t>Fourth level</a:t>
             </a:r>
           </a:p>
           <a:p>
             <a:pPr lvl="4"/>
             <a:r>
-              <a:rPr lang="en-US" smtClean="0"/>
+              <a:rPr lang="en-US"/>
               <a:t>Fifth level</a:t>
             </a:r>
-            <a:endParaRPr lang="en-US"/>
           </a:p>
         </p:txBody>
       </p:sp>
@@ -651,7 +661,7 @@
           <a:p>
             <a:fld id="{5BCAD085-E8A6-8845-BD4E-CB4CCA059FC4}" type="datetimeFigureOut">
               <a:rPr lang="en-US" smtClean="0"/>
-              <a:t>1/27/13</a:t>
+              <a:t>8/31/2026</a:t>
             </a:fld>
             <a:endParaRPr lang="en-US"/>
           </a:p>
@@ -745,10 +755,9 @@
           <a:lstStyle/>
           <a:p>
             <a:r>
-              <a:rPr lang="en-US" smtClean="0"/>
+              <a:rPr lang="en-US"/>
               <a:t>Click to edit Master title style</a:t>
             </a:r>
-            <a:endParaRPr lang="en-US"/>
           </a:p>
         </p:txBody>
       </p:sp>
@@ -769,38 +778,37 @@
           <a:p>
             <a:pPr lvl="0"/>
             <a:r>
-              <a:rPr lang="en-US" smtClean="0"/>
+              <a:rPr lang="en-US"/>
               <a:t>Click to edit Master text styles</a:t>
             </a:r>
           </a:p>
           <a:p>
             <a:pPr lvl="1"/>
             <a:r>
-              <a:rPr lang="en-US" smtClean="0"/>
+              <a:rPr lang="en-US"/>
               <a:t>Second level</a:t>
             </a:r>
           </a:p>
           <a:p>
             <a:pPr lvl="2"/>
             <a:r>
-              <a:rPr lang="en-US" smtClean="0"/>
+              <a:rPr lang="en-US"/>
               <a:t>Third level</a:t>
             </a:r>
           </a:p>
           <a:p>
             <a:pPr lvl="3"/>
             <a:r>
-              <a:rPr lang="en-US" smtClean="0"/>
+              <a:rPr lang="en-US"/>
               <a:t>Fourth level</a:t>
             </a:r>
           </a:p>
           <a:p>
             <a:pPr lvl="4"/>
             <a:r>
-              <a:rPr lang="en-US" smtClean="0"/>
+              <a:rPr lang="en-US"/>
               <a:t>Fifth level</a:t>
             </a:r>
-            <a:endParaRPr lang="en-US"/>
           </a:p>
         </p:txBody>
       </p:sp>
@@ -821,7 +829,7 @@
           <a:p>
             <a:fld id="{5BCAD085-E8A6-8845-BD4E-CB4CCA059FC4}" type="datetimeFigureOut">
               <a:rPr lang="en-US" smtClean="0"/>
-              <a:t>1/27/13</a:t>
+              <a:t>8/31/2026</a:t>
             </a:fld>
             <a:endParaRPr lang="en-US"/>
           </a:p>
@@ -924,10 +932,9 @@
           </a:lstStyle>
           <a:p>
             <a:r>
-              <a:rPr lang="en-US" smtClean="0"/>
+              <a:rPr lang="en-US"/>
               <a:t>Click to edit Master title style</a:t>
             </a:r>
-            <a:endParaRPr lang="en-US"/>
           </a:p>
         </p:txBody>
       </p:sp>
@@ -1044,7 +1051,7 @@
           <a:p>
             <a:pPr lvl="0"/>
             <a:r>
-              <a:rPr lang="en-US" smtClean="0"/>
+              <a:rPr lang="en-US"/>
               <a:t>Click to edit Master text styles</a:t>
             </a:r>
           </a:p>
@@ -1067,7 +1074,7 @@
           <a:p>
             <a:fld id="{5BCAD085-E8A6-8845-BD4E-CB4CCA059FC4}" type="datetimeFigureOut">
               <a:rPr lang="en-US" smtClean="0"/>
-              <a:t>1/27/13</a:t>
+              <a:t>8/31/2026</a:t>
             </a:fld>
             <a:endParaRPr lang="en-US"/>
           </a:p>
@@ -1161,10 +1168,9 @@
           <a:lstStyle/>
           <a:p>
             <a:r>
-              <a:rPr lang="en-US" smtClean="0"/>
+              <a:rPr lang="en-US"/>
               <a:t>Click to edit Master title style</a:t>
             </a:r>
-            <a:endParaRPr lang="en-US"/>
           </a:p>
         </p:txBody>
       </p:sp>
@@ -1218,38 +1224,37 @@
           <a:p>
             <a:pPr lvl="0"/>
             <a:r>
-              <a:rPr lang="en-US" smtClean="0"/>
+              <a:rPr lang="en-US"/>
               <a:t>Click to edit Master text styles</a:t>
             </a:r>
           </a:p>
           <a:p>
             <a:pPr lvl="1"/>
             <a:r>
-              <a:rPr lang="en-US" smtClean="0"/>
+              <a:rPr lang="en-US"/>
               <a:t>Second level</a:t>
             </a:r>
           </a:p>
           <a:p>
             <a:pPr lvl="2"/>
             <a:r>
-              <a:rPr lang="en-US" smtClean="0"/>
+              <a:rPr lang="en-US"/>
               <a:t>Third level</a:t>
             </a:r>
           </a:p>
           <a:p>
             <a:pPr lvl="3"/>
             <a:r>
-              <a:rPr lang="en-US" smtClean="0"/>
+              <a:rPr lang="en-US"/>
               <a:t>Fourth level</a:t>
             </a:r>
           </a:p>
           <a:p>
             <a:pPr lvl="4"/>
             <a:r>
-              <a:rPr lang="en-US" smtClean="0"/>
+              <a:rPr lang="en-US"/>
               <a:t>Fifth level</a:t>
             </a:r>
-            <a:endParaRPr lang="en-US"/>
           </a:p>
         </p:txBody>
       </p:sp>
@@ -1303,38 +1308,37 @@
           <a:p>
             <a:pPr lvl="0"/>
             <a:r>
-              <a:rPr lang="en-US" smtClean="0"/>
+              <a:rPr lang="en-US"/>
               <a:t>Click to edit Master text styles</a:t>
             </a:r>
           </a:p>
           <a:p>
             <a:pPr lvl="1"/>
             <a:r>
-              <a:rPr lang="en-US" smtClean="0"/>
+              <a:rPr lang="en-US"/>
               <a:t>Second level</a:t>
             </a:r>
           </a:p>
           <a:p>
             <a:pPr lvl="2"/>
             <a:r>
-              <a:rPr lang="en-US" smtClean="0"/>
+              <a:rPr lang="en-US"/>
               <a:t>Third level</a:t>
             </a:r>
           </a:p>
           <a:p>
             <a:pPr lvl="3"/>
             <a:r>
-              <a:rPr lang="en-US" smtClean="0"/>
+              <a:rPr lang="en-US"/>
               <a:t>Fourth level</a:t>
             </a:r>
           </a:p>
           <a:p>
             <a:pPr lvl="4"/>
             <a:r>
-              <a:rPr lang="en-US" smtClean="0"/>
+              <a:rPr lang="en-US"/>
               <a:t>Fifth level</a:t>
             </a:r>
-            <a:endParaRPr lang="en-US"/>
           </a:p>
         </p:txBody>
       </p:sp>
@@ -1355,7 +1359,7 @@
           <a:p>
             <a:fld id="{5BCAD085-E8A6-8845-BD4E-CB4CCA059FC4}" type="datetimeFigureOut">
               <a:rPr lang="en-US" smtClean="0"/>
-              <a:t>1/27/13</a:t>
+              <a:t>8/31/2026</a:t>
             </a:fld>
             <a:endParaRPr lang="en-US"/>
           </a:p>
@@ -1453,10 +1457,9 @@
           </a:lstStyle>
           <a:p>
             <a:r>
-              <a:rPr lang="en-US" smtClean="0"/>
+              <a:rPr lang="en-US"/>
               <a:t>Click to edit Master title style</a:t>
             </a:r>
-            <a:endParaRPr lang="en-US"/>
           </a:p>
         </p:txBody>
       </p:sp>
@@ -1519,7 +1522,7 @@
           <a:p>
             <a:pPr lvl="0"/>
             <a:r>
-              <a:rPr lang="en-US" smtClean="0"/>
+              <a:rPr lang="en-US"/>
               <a:t>Click to edit Master text styles</a:t>
             </a:r>
           </a:p>
@@ -1575,38 +1578,37 @@
           <a:p>
             <a:pPr lvl="0"/>
             <a:r>
-              <a:rPr lang="en-US" smtClean="0"/>
+              <a:rPr lang="en-US"/>
               <a:t>Click to edit Master text styles</a:t>
             </a:r>
           </a:p>
           <a:p>
             <a:pPr lvl="1"/>
             <a:r>
-              <a:rPr lang="en-US" smtClean="0"/>
+              <a:rPr lang="en-US"/>
               <a:t>Second level</a:t>
             </a:r>
           </a:p>
           <a:p>
             <a:pPr lvl="2"/>
             <a:r>
-              <a:rPr lang="en-US" smtClean="0"/>
+              <a:rPr lang="en-US"/>
               <a:t>Third level</a:t>
             </a:r>
           </a:p>
           <a:p>
             <a:pPr lvl="3"/>
             <a:r>
-              <a:rPr lang="en-US" smtClean="0"/>
+              <a:rPr lang="en-US"/>
               <a:t>Fourth level</a:t>
             </a:r>
           </a:p>
           <a:p>
             <a:pPr lvl="4"/>
             <a:r>
-              <a:rPr lang="en-US" smtClean="0"/>
+              <a:rPr lang="en-US"/>
               <a:t>Fifth level</a:t>
             </a:r>
-            <a:endParaRPr lang="en-US"/>
           </a:p>
         </p:txBody>
       </p:sp>
@@ -1669,7 +1671,7 @@
           <a:p>
             <a:pPr lvl="0"/>
             <a:r>
-              <a:rPr lang="en-US" smtClean="0"/>
+              <a:rPr lang="en-US"/>
               <a:t>Click to edit Master text styles</a:t>
             </a:r>
           </a:p>
@@ -1725,38 +1727,37 @@
           <a:p>
             <a:pPr lvl="0"/>
             <a:r>
-              <a:rPr lang="en-US" smtClean="0"/>
+              <a:rPr lang="en-US"/>
               <a:t>Click to edit Master text styles</a:t>
             </a:r>
           </a:p>
           <a:p>
             <a:pPr lvl="1"/>
             <a:r>
-              <a:rPr lang="en-US" smtClean="0"/>
+              <a:rPr lang="en-US"/>
               <a:t>Second level</a:t>
             </a:r>
           </a:p>
           <a:p>
             <a:pPr lvl="2"/>
             <a:r>
-              <a:rPr lang="en-US" smtClean="0"/>
+              <a:rPr lang="en-US"/>
               <a:t>Third level</a:t>
             </a:r>
           </a:p>
           <a:p>
             <a:pPr lvl="3"/>
             <a:r>
-              <a:rPr lang="en-US" smtClean="0"/>
+              <a:rPr lang="en-US"/>
               <a:t>Fourth level</a:t>
             </a:r>
           </a:p>
           <a:p>
             <a:pPr lvl="4"/>
             <a:r>
-              <a:rPr lang="en-US" smtClean="0"/>
+              <a:rPr lang="en-US"/>
               <a:t>Fifth level</a:t>
             </a:r>
-            <a:endParaRPr lang="en-US"/>
           </a:p>
         </p:txBody>
       </p:sp>
@@ -1777,7 +1778,7 @@
           <a:p>
             <a:fld id="{5BCAD085-E8A6-8845-BD4E-CB4CCA059FC4}" type="datetimeFigureOut">
               <a:rPr lang="en-US" smtClean="0"/>
-              <a:t>1/27/13</a:t>
+              <a:t>8/31/2026</a:t>
             </a:fld>
             <a:endParaRPr lang="en-US"/>
           </a:p>
@@ -1871,10 +1872,9 @@
           <a:lstStyle/>
           <a:p>
             <a:r>
-              <a:rPr lang="en-US" smtClean="0"/>
+              <a:rPr lang="en-US"/>
               <a:t>Click to edit Master title style</a:t>
             </a:r>
-            <a:endParaRPr lang="en-US"/>
           </a:p>
         </p:txBody>
       </p:sp>
@@ -1895,7 +1895,7 @@
           <a:p>
             <a:fld id="{5BCAD085-E8A6-8845-BD4E-CB4CCA059FC4}" type="datetimeFigureOut">
               <a:rPr lang="en-US" smtClean="0"/>
-              <a:t>1/27/13</a:t>
+              <a:t>8/31/2026</a:t>
             </a:fld>
             <a:endParaRPr lang="en-US"/>
           </a:p>
@@ -1990,7 +1990,7 @@
           <a:p>
             <a:fld id="{5BCAD085-E8A6-8845-BD4E-CB4CCA059FC4}" type="datetimeFigureOut">
               <a:rPr lang="en-US" smtClean="0"/>
-              <a:t>1/27/13</a:t>
+              <a:t>8/31/2026</a:t>
             </a:fld>
             <a:endParaRPr lang="en-US"/>
           </a:p>
@@ -2093,10 +2093,9 @@
           </a:lstStyle>
           <a:p>
             <a:r>
-              <a:rPr lang="en-US" smtClean="0"/>
+              <a:rPr lang="en-US"/>
               <a:t>Click to edit Master title style</a:t>
             </a:r>
-            <a:endParaRPr lang="en-US"/>
           </a:p>
         </p:txBody>
       </p:sp>
@@ -2150,38 +2149,37 @@
           <a:p>
             <a:pPr lvl="0"/>
             <a:r>
-              <a:rPr lang="en-US" smtClean="0"/>
+              <a:rPr lang="en-US"/>
               <a:t>Click to edit Master text styles</a:t>
             </a:r>
           </a:p>
           <a:p>
             <a:pPr lvl="1"/>
             <a:r>
-              <a:rPr lang="en-US" smtClean="0"/>
+              <a:rPr lang="en-US"/>
               <a:t>Second level</a:t>
             </a:r>
           </a:p>
           <a:p>
             <a:pPr lvl="2"/>
             <a:r>
-              <a:rPr lang="en-US" smtClean="0"/>
+              <a:rPr lang="en-US"/>
               <a:t>Third level</a:t>
             </a:r>
           </a:p>
           <a:p>
             <a:pPr lvl="3"/>
             <a:r>
-              <a:rPr lang="en-US" smtClean="0"/>
+              <a:rPr lang="en-US"/>
               <a:t>Fourth level</a:t>
             </a:r>
           </a:p>
           <a:p>
             <a:pPr lvl="4"/>
             <a:r>
-              <a:rPr lang="en-US" smtClean="0"/>
+              <a:rPr lang="en-US"/>
               <a:t>Fifth level</a:t>
             </a:r>
-            <a:endParaRPr lang="en-US"/>
           </a:p>
         </p:txBody>
       </p:sp>
@@ -2244,7 +2242,7 @@
           <a:p>
             <a:pPr lvl="0"/>
             <a:r>
-              <a:rPr lang="en-US" smtClean="0"/>
+              <a:rPr lang="en-US"/>
               <a:t>Click to edit Master text styles</a:t>
             </a:r>
           </a:p>
@@ -2267,7 +2265,7 @@
           <a:p>
             <a:fld id="{5BCAD085-E8A6-8845-BD4E-CB4CCA059FC4}" type="datetimeFigureOut">
               <a:rPr lang="en-US" smtClean="0"/>
-              <a:t>1/27/13</a:t>
+              <a:t>8/31/2026</a:t>
             </a:fld>
             <a:endParaRPr lang="en-US"/>
           </a:p>
@@ -2370,10 +2368,9 @@
           </a:lstStyle>
           <a:p>
             <a:r>
-              <a:rPr lang="en-US" smtClean="0"/>
+              <a:rPr lang="en-US"/>
               <a:t>Click to edit Master title style</a:t>
             </a:r>
-            <a:endParaRPr lang="en-US"/>
           </a:p>
         </p:txBody>
       </p:sp>
@@ -2497,7 +2494,7 @@
           <a:p>
             <a:pPr lvl="0"/>
             <a:r>
-              <a:rPr lang="en-US" smtClean="0"/>
+              <a:rPr lang="en-US"/>
               <a:t>Click to edit Master text styles</a:t>
             </a:r>
           </a:p>
@@ -2520,7 +2517,7 @@
           <a:p>
             <a:fld id="{5BCAD085-E8A6-8845-BD4E-CB4CCA059FC4}" type="datetimeFigureOut">
               <a:rPr lang="en-US" smtClean="0"/>
-              <a:t>1/27/13</a:t>
+              <a:t>8/31/2026</a:t>
             </a:fld>
             <a:endParaRPr lang="en-US"/>
           </a:p>
@@ -2629,10 +2626,9 @@
           <a:lstStyle/>
           <a:p>
             <a:r>
-              <a:rPr lang="en-US" smtClean="0"/>
+              <a:rPr lang="en-US"/>
               <a:t>Click to edit Master title style</a:t>
             </a:r>
-            <a:endParaRPr lang="en-US"/>
           </a:p>
         </p:txBody>
       </p:sp>
@@ -2663,38 +2659,37 @@
           <a:p>
             <a:pPr lvl="0"/>
             <a:r>
-              <a:rPr lang="en-US" smtClean="0"/>
+              <a:rPr lang="en-US"/>
               <a:t>Click to edit Master text styles</a:t>
             </a:r>
           </a:p>
           <a:p>
             <a:pPr lvl="1"/>
             <a:r>
-              <a:rPr lang="en-US" smtClean="0"/>
+              <a:rPr lang="en-US"/>
               <a:t>Second level</a:t>
             </a:r>
           </a:p>
           <a:p>
             <a:pPr lvl="2"/>
             <a:r>
-              <a:rPr lang="en-US" smtClean="0"/>
+              <a:rPr lang="en-US"/>
               <a:t>Third level</a:t>
             </a:r>
           </a:p>
           <a:p>
             <a:pPr lvl="3"/>
             <a:r>
-              <a:rPr lang="en-US" smtClean="0"/>
+              <a:rPr lang="en-US"/>
               <a:t>Fourth level</a:t>
             </a:r>
           </a:p>
           <a:p>
             <a:pPr lvl="4"/>
             <a:r>
-              <a:rPr lang="en-US" smtClean="0"/>
+              <a:rPr lang="en-US"/>
               <a:t>Fifth level</a:t>
             </a:r>
-            <a:endParaRPr lang="en-US"/>
           </a:p>
         </p:txBody>
       </p:sp>
@@ -2733,7 +2728,7 @@
           <a:p>
             <a:fld id="{5BCAD085-E8A6-8845-BD4E-CB4CCA059FC4}" type="datetimeFigureOut">
               <a:rPr lang="en-US" smtClean="0"/>
-              <a:t>1/27/13</a:t>
+              <a:t>8/31/2026</a:t>
             </a:fld>
             <a:endParaRPr lang="en-US"/>
           </a:p>
@@ -3092,7 +3087,7 @@
 </file>
 
 <file path=ppt/slides/slide1.xml><?xml version="1.0" encoding="utf-8"?>
-<p:sld xmlns:a="http://schemas.openxmlformats.org/drawingml/2006/main" xmlns:p="http://schemas.openxmlformats.org/presentationml/2006/main" xmlns:r="http://schemas.openxmlformats.org/officeDocument/2006/relationships">
+<p:sld xmlns:a="http://schemas.openxmlformats.org/drawingml/2006/main" xmlns:r="http://schemas.openxmlformats.org/officeDocument/2006/relationships" xmlns:p="http://schemas.openxmlformats.org/presentationml/2006/main">
   <p:cSld>
     <p:spTree>
       <p:nvGrpSpPr>
@@ -3100,7 +3095,14 @@
         <p:cNvGrpSpPr/>
         <p:nvPr/>
       </p:nvGrpSpPr>
-      <p:grpSpPr/>
+      <p:grpSpPr>
+        <a:xfrm>
+          <a:off x="0" y="0"/>
+          <a:ext cx="0" cy="0"/>
+          <a:chOff x="0" y="0"/>
+          <a:chExt cx="0" cy="0"/>
+        </a:xfrm>
+      </p:grpSpPr>
       <p:sp>
         <p:nvSpPr>
           <p:cNvPr id="2" name="Rectangle 1"/>
@@ -3109,7 +3111,7 @@
         </p:nvSpPr>
         <p:spPr>
           <a:xfrm>
-            <a:off x="0" y="0"/>
+            <a:off x="18288" y="0"/>
             <a:ext cx="12191695" cy="6858000"/>
           </a:xfrm>
           <a:prstGeom prst="rect">
@@ -3141,6 +3143,7 @@
           <a:lstStyle/>
           <a:p>
             <a:pPr algn="ctr"/>
+            <a:endParaRPr/>
           </a:p>
         </p:txBody>
       </p:sp>
@@ -3152,8 +3155,8 @@
         </p:nvSpPr>
         <p:spPr>
           <a:xfrm>
-            <a:off x="1097280" y="1645920"/>
-            <a:ext cx="10058400" cy="4114800"/>
+            <a:off x="1066800" y="2408207"/>
+            <a:ext cx="10058400" cy="2041585"/>
           </a:xfrm>
           <a:prstGeom prst="rect">
             <a:avLst/>
@@ -3177,6 +3180,7 @@
               </a:defRPr>
             </a:pPr>
             <a:r>
+              <a:rPr dirty="0"/>
               <a:t>GENAI PINNACLE PLUS PROGRAM • FINAL CAPSTONE PROJECT</a:t>
             </a:r>
           </a:p>
@@ -3192,6 +3196,7 @@
               </a:defRPr>
             </a:pPr>
             <a:r>
+              <a:rPr dirty="0"/>
               <a:t>Research Paper Answer Bot</a:t>
             </a:r>
           </a:p>
@@ -3207,6 +3212,7 @@
               </a:defRPr>
             </a:pPr>
             <a:r>
+              <a:rPr dirty="0"/>
               <a:t>A Grounded RAG Pipeline with Multi-Strategy Retrieval, Exact Page Citations &amp; Zero Hallucinations</a:t>
             </a:r>
           </a:p>
@@ -3219,8 +3225,38 @@
               </a:defRPr>
             </a:pPr>
             <a:r>
-              <a:t>Author: Candidate Submission  |  Date: August 2026  |  Tech Stack: Python, LangChain, Google Gemini, ChromaDB, Streamlit</a:t>
-            </a:r>
+              <a:rPr sz="1500" dirty="0"/>
+              <a:t>Author: </a:t>
+            </a:r>
+            <a:r>
+              <a:rPr lang="en-IN" sz="1500" dirty="0"/>
+              <a:t> SANJAI S</a:t>
+            </a:r>
+            <a:r>
+              <a:rPr sz="1500" dirty="0"/>
+              <a:t>  |  Date: August 2026  |  Tech Stack: Python, </a:t>
+            </a:r>
+            <a:r>
+              <a:rPr sz="1500" dirty="0" err="1"/>
+              <a:t>LangChain</a:t>
+            </a:r>
+            <a:r>
+              <a:rPr sz="1500" dirty="0"/>
+              <a:t>, Google Gemini, </a:t>
+            </a:r>
+            <a:r>
+              <a:rPr sz="1500" dirty="0" err="1"/>
+              <a:t>ChromaDB</a:t>
+            </a:r>
+            <a:r>
+              <a:rPr sz="1500" dirty="0"/>
+              <a:t>, </a:t>
+            </a:r>
+            <a:r>
+              <a:rPr sz="1500" dirty="0" err="1"/>
+              <a:t>Streamlit</a:t>
+            </a:r>
+            <a:endParaRPr sz="1500" dirty="0"/>
           </a:p>
         </p:txBody>
       </p:sp>
@@ -3233,7 +3269,7 @@
 </file>
 
 <file path=ppt/slides/slide10.xml><?xml version="1.0" encoding="utf-8"?>
-<p:sld xmlns:a="http://schemas.openxmlformats.org/drawingml/2006/main" xmlns:p="http://schemas.openxmlformats.org/presentationml/2006/main" xmlns:r="http://schemas.openxmlformats.org/officeDocument/2006/relationships">
+<p:sld xmlns:a="http://schemas.openxmlformats.org/drawingml/2006/main" xmlns:r="http://schemas.openxmlformats.org/officeDocument/2006/relationships" xmlns:p="http://schemas.openxmlformats.org/presentationml/2006/main">
   <p:cSld>
     <p:spTree>
       <p:nvGrpSpPr>
@@ -3241,7 +3277,14 @@
         <p:cNvGrpSpPr/>
         <p:nvPr/>
       </p:nvGrpSpPr>
-      <p:grpSpPr/>
+      <p:grpSpPr>
+        <a:xfrm>
+          <a:off x="0" y="0"/>
+          <a:ext cx="0" cy="0"/>
+          <a:chOff x="0" y="0"/>
+          <a:chExt cx="0" cy="0"/>
+        </a:xfrm>
+      </p:grpSpPr>
       <p:sp>
         <p:nvSpPr>
           <p:cNvPr id="2" name="Rectangle 1"/>
@@ -3284,6 +3327,7 @@
           <a:lstStyle/>
           <a:p>
             <a:pPr algn="ctr"/>
+            <a:endParaRPr/>
           </a:p>
         </p:txBody>
       </p:sp>
@@ -3414,6 +3458,7 @@
           <a:lstStyle/>
           <a:p>
             <a:pPr algn="ctr"/>
+            <a:endParaRPr/>
           </a:p>
         </p:txBody>
       </p:sp>
@@ -3572,6 +3617,7 @@
           <a:lstStyle/>
           <a:p>
             <a:pPr algn="ctr"/>
+            <a:endParaRPr/>
           </a:p>
         </p:txBody>
       </p:sp>
@@ -3697,7 +3743,7 @@
 </file>
 
 <file path=ppt/slides/slide11.xml><?xml version="1.0" encoding="utf-8"?>
-<p:sld xmlns:a="http://schemas.openxmlformats.org/drawingml/2006/main" xmlns:p="http://schemas.openxmlformats.org/presentationml/2006/main" xmlns:r="http://schemas.openxmlformats.org/officeDocument/2006/relationships">
+<p:sld xmlns:a="http://schemas.openxmlformats.org/drawingml/2006/main" xmlns:r="http://schemas.openxmlformats.org/officeDocument/2006/relationships" xmlns:p="http://schemas.openxmlformats.org/presentationml/2006/main">
   <p:cSld>
     <p:spTree>
       <p:nvGrpSpPr>
@@ -3705,7 +3751,14 @@
         <p:cNvGrpSpPr/>
         <p:nvPr/>
       </p:nvGrpSpPr>
-      <p:grpSpPr/>
+      <p:grpSpPr>
+        <a:xfrm>
+          <a:off x="0" y="0"/>
+          <a:ext cx="0" cy="0"/>
+          <a:chOff x="0" y="0"/>
+          <a:chExt cx="0" cy="0"/>
+        </a:xfrm>
+      </p:grpSpPr>
       <p:sp>
         <p:nvSpPr>
           <p:cNvPr id="2" name="Rectangle 1"/>
@@ -3748,6 +3801,7 @@
           <a:lstStyle/>
           <a:p>
             <a:pPr algn="ctr"/>
+            <a:endParaRPr/>
           </a:p>
         </p:txBody>
       </p:sp>
@@ -3869,7 +3923,7 @@
 </file>
 
 <file path=ppt/slides/slide12.xml><?xml version="1.0" encoding="utf-8"?>
-<p:sld xmlns:a="http://schemas.openxmlformats.org/drawingml/2006/main" xmlns:p="http://schemas.openxmlformats.org/presentationml/2006/main" xmlns:r="http://schemas.openxmlformats.org/officeDocument/2006/relationships">
+<p:sld xmlns:a="http://schemas.openxmlformats.org/drawingml/2006/main" xmlns:r="http://schemas.openxmlformats.org/officeDocument/2006/relationships" xmlns:p="http://schemas.openxmlformats.org/presentationml/2006/main">
   <p:cSld>
     <p:spTree>
       <p:nvGrpSpPr>
@@ -3877,7 +3931,14 @@
         <p:cNvGrpSpPr/>
         <p:nvPr/>
       </p:nvGrpSpPr>
-      <p:grpSpPr/>
+      <p:grpSpPr>
+        <a:xfrm>
+          <a:off x="0" y="0"/>
+          <a:ext cx="0" cy="0"/>
+          <a:chOff x="0" y="0"/>
+          <a:chExt cx="0" cy="0"/>
+        </a:xfrm>
+      </p:grpSpPr>
       <p:sp>
         <p:nvSpPr>
           <p:cNvPr id="2" name="Rectangle 1"/>
@@ -3920,6 +3981,7 @@
           <a:lstStyle/>
           <a:p>
             <a:pPr algn="ctr"/>
+            <a:endParaRPr/>
           </a:p>
         </p:txBody>
       </p:sp>
@@ -4050,6 +4112,7 @@
           <a:lstStyle/>
           <a:p>
             <a:pPr algn="ctr"/>
+            <a:endParaRPr/>
           </a:p>
         </p:txBody>
       </p:sp>
@@ -4175,7 +4238,7 @@
 </file>
 
 <file path=ppt/slides/slide13.xml><?xml version="1.0" encoding="utf-8"?>
-<p:sld xmlns:a="http://schemas.openxmlformats.org/drawingml/2006/main" xmlns:p="http://schemas.openxmlformats.org/presentationml/2006/main" xmlns:r="http://schemas.openxmlformats.org/officeDocument/2006/relationships">
+<p:sld xmlns:a="http://schemas.openxmlformats.org/drawingml/2006/main" xmlns:r="http://schemas.openxmlformats.org/officeDocument/2006/relationships" xmlns:p="http://schemas.openxmlformats.org/presentationml/2006/main">
   <p:cSld>
     <p:spTree>
       <p:nvGrpSpPr>
@@ -4183,7 +4246,14 @@
         <p:cNvGrpSpPr/>
         <p:nvPr/>
       </p:nvGrpSpPr>
-      <p:grpSpPr/>
+      <p:grpSpPr>
+        <a:xfrm>
+          <a:off x="0" y="0"/>
+          <a:ext cx="0" cy="0"/>
+          <a:chOff x="0" y="0"/>
+          <a:chExt cx="0" cy="0"/>
+        </a:xfrm>
+      </p:grpSpPr>
       <p:sp>
         <p:nvSpPr>
           <p:cNvPr id="2" name="Rectangle 1"/>
@@ -4226,6 +4296,7 @@
           <a:lstStyle/>
           <a:p>
             <a:pPr algn="ctr"/>
+            <a:endParaRPr/>
           </a:p>
         </p:txBody>
       </p:sp>
@@ -4356,6 +4427,7 @@
           <a:lstStyle/>
           <a:p>
             <a:pPr algn="ctr"/>
+            <a:endParaRPr/>
           </a:p>
         </p:txBody>
       </p:sp>
@@ -4499,6 +4571,7 @@
           <a:lstStyle/>
           <a:p>
             <a:pPr algn="ctr"/>
+            <a:endParaRPr/>
           </a:p>
         </p:txBody>
       </p:sp>
@@ -4609,7 +4682,7 @@
 </file>
 
 <file path=ppt/slides/slide14.xml><?xml version="1.0" encoding="utf-8"?>
-<p:sld xmlns:a="http://schemas.openxmlformats.org/drawingml/2006/main" xmlns:p="http://schemas.openxmlformats.org/presentationml/2006/main" xmlns:r="http://schemas.openxmlformats.org/officeDocument/2006/relationships">
+<p:sld xmlns:a="http://schemas.openxmlformats.org/drawingml/2006/main" xmlns:r="http://schemas.openxmlformats.org/officeDocument/2006/relationships" xmlns:p="http://schemas.openxmlformats.org/presentationml/2006/main">
   <p:cSld>
     <p:spTree>
       <p:nvGrpSpPr>
@@ -4617,7 +4690,14 @@
         <p:cNvGrpSpPr/>
         <p:nvPr/>
       </p:nvGrpSpPr>
-      <p:grpSpPr/>
+      <p:grpSpPr>
+        <a:xfrm>
+          <a:off x="0" y="0"/>
+          <a:ext cx="0" cy="0"/>
+          <a:chOff x="0" y="0"/>
+          <a:chExt cx="0" cy="0"/>
+        </a:xfrm>
+      </p:grpSpPr>
       <p:sp>
         <p:nvSpPr>
           <p:cNvPr id="2" name="Rectangle 1"/>
@@ -4660,6 +4740,7 @@
           <a:lstStyle/>
           <a:p>
             <a:pPr algn="ctr"/>
+            <a:endParaRPr/>
           </a:p>
         </p:txBody>
       </p:sp>
@@ -4790,6 +4871,7 @@
           <a:lstStyle/>
           <a:p>
             <a:pPr algn="ctr"/>
+            <a:endParaRPr/>
           </a:p>
         </p:txBody>
       </p:sp>
@@ -4948,6 +5030,7 @@
           <a:lstStyle/>
           <a:p>
             <a:pPr algn="ctr"/>
+            <a:endParaRPr/>
           </a:p>
         </p:txBody>
       </p:sp>
@@ -5058,7 +5141,7 @@
 </file>
 
 <file path=ppt/slides/slide2.xml><?xml version="1.0" encoding="utf-8"?>
-<p:sld xmlns:a="http://schemas.openxmlformats.org/drawingml/2006/main" xmlns:p="http://schemas.openxmlformats.org/presentationml/2006/main" xmlns:r="http://schemas.openxmlformats.org/officeDocument/2006/relationships">
+<p:sld xmlns:a="http://schemas.openxmlformats.org/drawingml/2006/main" xmlns:r="http://schemas.openxmlformats.org/officeDocument/2006/relationships" xmlns:p="http://schemas.openxmlformats.org/presentationml/2006/main">
   <p:cSld>
     <p:spTree>
       <p:nvGrpSpPr>
@@ -5066,7 +5149,14 @@
         <p:cNvGrpSpPr/>
         <p:nvPr/>
       </p:nvGrpSpPr>
-      <p:grpSpPr/>
+      <p:grpSpPr>
+        <a:xfrm>
+          <a:off x="0" y="0"/>
+          <a:ext cx="0" cy="0"/>
+          <a:chOff x="0" y="0"/>
+          <a:chExt cx="0" cy="0"/>
+        </a:xfrm>
+      </p:grpSpPr>
       <p:sp>
         <p:nvSpPr>
           <p:cNvPr id="2" name="Rectangle 1"/>
@@ -5109,6 +5199,7 @@
           <a:lstStyle/>
           <a:p>
             <a:pPr algn="ctr"/>
+            <a:endParaRPr/>
           </a:p>
         </p:txBody>
       </p:sp>
@@ -5239,6 +5330,7 @@
           <a:lstStyle/>
           <a:p>
             <a:pPr algn="ctr"/>
+            <a:endParaRPr/>
           </a:p>
         </p:txBody>
       </p:sp>
@@ -5367,6 +5459,7 @@
           <a:lstStyle/>
           <a:p>
             <a:pPr algn="ctr"/>
+            <a:endParaRPr/>
           </a:p>
         </p:txBody>
       </p:sp>
@@ -5495,6 +5588,7 @@
           <a:lstStyle/>
           <a:p>
             <a:pPr algn="ctr"/>
+            <a:endParaRPr/>
           </a:p>
         </p:txBody>
       </p:sp>
@@ -5605,7 +5699,7 @@
 </file>
 
 <file path=ppt/slides/slide3.xml><?xml version="1.0" encoding="utf-8"?>
-<p:sld xmlns:a="http://schemas.openxmlformats.org/drawingml/2006/main" xmlns:p="http://schemas.openxmlformats.org/presentationml/2006/main" xmlns:r="http://schemas.openxmlformats.org/officeDocument/2006/relationships">
+<p:sld xmlns:a="http://schemas.openxmlformats.org/drawingml/2006/main" xmlns:r="http://schemas.openxmlformats.org/officeDocument/2006/relationships" xmlns:p="http://schemas.openxmlformats.org/presentationml/2006/main">
   <p:cSld>
     <p:spTree>
       <p:nvGrpSpPr>
@@ -5613,7 +5707,14 @@
         <p:cNvGrpSpPr/>
         <p:nvPr/>
       </p:nvGrpSpPr>
-      <p:grpSpPr/>
+      <p:grpSpPr>
+        <a:xfrm>
+          <a:off x="0" y="0"/>
+          <a:ext cx="0" cy="0"/>
+          <a:chOff x="0" y="0"/>
+          <a:chExt cx="0" cy="0"/>
+        </a:xfrm>
+      </p:grpSpPr>
       <p:sp>
         <p:nvSpPr>
           <p:cNvPr id="2" name="Rectangle 1"/>
@@ -5656,6 +5757,7 @@
           <a:lstStyle/>
           <a:p>
             <a:pPr algn="ctr"/>
+            <a:endParaRPr/>
           </a:p>
         </p:txBody>
       </p:sp>
@@ -5786,6 +5888,7 @@
           <a:lstStyle/>
           <a:p>
             <a:pPr algn="ctr"/>
+            <a:endParaRPr/>
           </a:p>
         </p:txBody>
       </p:sp>
@@ -5956,6 +6059,7 @@
           <a:lstStyle/>
           <a:p>
             <a:pPr algn="ctr"/>
+            <a:endParaRPr/>
           </a:p>
         </p:txBody>
       </p:sp>
@@ -6126,6 +6230,7 @@
           <a:lstStyle/>
           <a:p>
             <a:pPr algn="ctr"/>
+            <a:endParaRPr/>
           </a:p>
         </p:txBody>
       </p:sp>
@@ -6296,6 +6401,7 @@
           <a:lstStyle/>
           <a:p>
             <a:pPr algn="ctr"/>
+            <a:endParaRPr/>
           </a:p>
         </p:txBody>
       </p:sp>
@@ -6433,7 +6539,7 @@
 </file>
 
 <file path=ppt/slides/slide4.xml><?xml version="1.0" encoding="utf-8"?>
-<p:sld xmlns:a="http://schemas.openxmlformats.org/drawingml/2006/main" xmlns:p="http://schemas.openxmlformats.org/presentationml/2006/main" xmlns:r="http://schemas.openxmlformats.org/officeDocument/2006/relationships">
+<p:sld xmlns:a="http://schemas.openxmlformats.org/drawingml/2006/main" xmlns:r="http://schemas.openxmlformats.org/officeDocument/2006/relationships" xmlns:p="http://schemas.openxmlformats.org/presentationml/2006/main">
   <p:cSld>
     <p:spTree>
       <p:nvGrpSpPr>
@@ -6441,7 +6547,14 @@
         <p:cNvGrpSpPr/>
         <p:nvPr/>
       </p:nvGrpSpPr>
-      <p:grpSpPr/>
+      <p:grpSpPr>
+        <a:xfrm>
+          <a:off x="0" y="0"/>
+          <a:ext cx="0" cy="0"/>
+          <a:chOff x="0" y="0"/>
+          <a:chExt cx="0" cy="0"/>
+        </a:xfrm>
+      </p:grpSpPr>
       <p:sp>
         <p:nvSpPr>
           <p:cNvPr id="2" name="Rectangle 1"/>
@@ -6484,6 +6597,7 @@
           <a:lstStyle/>
           <a:p>
             <a:pPr algn="ctr"/>
+            <a:endParaRPr/>
           </a:p>
         </p:txBody>
       </p:sp>
@@ -6605,7 +6719,7 @@
 </file>
 
 <file path=ppt/slides/slide5.xml><?xml version="1.0" encoding="utf-8"?>
-<p:sld xmlns:a="http://schemas.openxmlformats.org/drawingml/2006/main" xmlns:p="http://schemas.openxmlformats.org/presentationml/2006/main" xmlns:r="http://schemas.openxmlformats.org/officeDocument/2006/relationships">
+<p:sld xmlns:a="http://schemas.openxmlformats.org/drawingml/2006/main" xmlns:r="http://schemas.openxmlformats.org/officeDocument/2006/relationships" xmlns:p="http://schemas.openxmlformats.org/presentationml/2006/main">
   <p:cSld>
     <p:spTree>
       <p:nvGrpSpPr>
@@ -6613,7 +6727,14 @@
         <p:cNvGrpSpPr/>
         <p:nvPr/>
       </p:nvGrpSpPr>
-      <p:grpSpPr/>
+      <p:grpSpPr>
+        <a:xfrm>
+          <a:off x="0" y="0"/>
+          <a:ext cx="0" cy="0"/>
+          <a:chOff x="0" y="0"/>
+          <a:chExt cx="0" cy="0"/>
+        </a:xfrm>
+      </p:grpSpPr>
       <p:sp>
         <p:nvSpPr>
           <p:cNvPr id="2" name="Rectangle 1"/>
@@ -6656,6 +6777,7 @@
           <a:lstStyle/>
           <a:p>
             <a:pPr algn="ctr"/>
+            <a:endParaRPr/>
           </a:p>
         </p:txBody>
       </p:sp>
@@ -6786,6 +6908,7 @@
           <a:lstStyle/>
           <a:p>
             <a:pPr algn="ctr"/>
+            <a:endParaRPr/>
           </a:p>
         </p:txBody>
       </p:sp>
@@ -6959,6 +7082,7 @@
           <a:lstStyle/>
           <a:p>
             <a:pPr algn="ctr"/>
+            <a:endParaRPr/>
           </a:p>
         </p:txBody>
       </p:sp>
@@ -7099,7 +7223,7 @@
 </file>
 
 <file path=ppt/slides/slide6.xml><?xml version="1.0" encoding="utf-8"?>
-<p:sld xmlns:a="http://schemas.openxmlformats.org/drawingml/2006/main" xmlns:p="http://schemas.openxmlformats.org/presentationml/2006/main" xmlns:r="http://schemas.openxmlformats.org/officeDocument/2006/relationships">
+<p:sld xmlns:a="http://schemas.openxmlformats.org/drawingml/2006/main" xmlns:r="http://schemas.openxmlformats.org/officeDocument/2006/relationships" xmlns:p="http://schemas.openxmlformats.org/presentationml/2006/main">
   <p:cSld>
     <p:spTree>
       <p:nvGrpSpPr>
@@ -7107,7 +7231,14 @@
         <p:cNvGrpSpPr/>
         <p:nvPr/>
       </p:nvGrpSpPr>
-      <p:grpSpPr/>
+      <p:grpSpPr>
+        <a:xfrm>
+          <a:off x="0" y="0"/>
+          <a:ext cx="0" cy="0"/>
+          <a:chOff x="0" y="0"/>
+          <a:chExt cx="0" cy="0"/>
+        </a:xfrm>
+      </p:grpSpPr>
       <p:sp>
         <p:nvSpPr>
           <p:cNvPr id="2" name="Rectangle 1"/>
@@ -7150,6 +7281,7 @@
           <a:lstStyle/>
           <a:p>
             <a:pPr algn="ctr"/>
+            <a:endParaRPr/>
           </a:p>
         </p:txBody>
       </p:sp>
@@ -7280,6 +7412,7 @@
           <a:lstStyle/>
           <a:p>
             <a:pPr algn="ctr"/>
+            <a:endParaRPr/>
           </a:p>
         </p:txBody>
       </p:sp>
@@ -7438,6 +7571,7 @@
           <a:lstStyle/>
           <a:p>
             <a:pPr algn="ctr"/>
+            <a:endParaRPr/>
           </a:p>
         </p:txBody>
       </p:sp>
@@ -7548,7 +7682,7 @@
 </file>
 
 <file path=ppt/slides/slide7.xml><?xml version="1.0" encoding="utf-8"?>
-<p:sld xmlns:a="http://schemas.openxmlformats.org/drawingml/2006/main" xmlns:p="http://schemas.openxmlformats.org/presentationml/2006/main" xmlns:r="http://schemas.openxmlformats.org/officeDocument/2006/relationships">
+<p:sld xmlns:a="http://schemas.openxmlformats.org/drawingml/2006/main" xmlns:r="http://schemas.openxmlformats.org/officeDocument/2006/relationships" xmlns:p="http://schemas.openxmlformats.org/presentationml/2006/main">
   <p:cSld>
     <p:spTree>
       <p:nvGrpSpPr>
@@ -7556,7 +7690,14 @@
         <p:cNvGrpSpPr/>
         <p:nvPr/>
       </p:nvGrpSpPr>
-      <p:grpSpPr/>
+      <p:grpSpPr>
+        <a:xfrm>
+          <a:off x="0" y="0"/>
+          <a:ext cx="0" cy="0"/>
+          <a:chOff x="0" y="0"/>
+          <a:chExt cx="0" cy="0"/>
+        </a:xfrm>
+      </p:grpSpPr>
       <p:sp>
         <p:nvSpPr>
           <p:cNvPr id="2" name="Rectangle 1"/>
@@ -7599,6 +7740,7 @@
           <a:lstStyle/>
           <a:p>
             <a:pPr algn="ctr"/>
+            <a:endParaRPr/>
           </a:p>
         </p:txBody>
       </p:sp>
@@ -7729,6 +7871,7 @@
           <a:lstStyle/>
           <a:p>
             <a:pPr algn="ctr"/>
+            <a:endParaRPr/>
           </a:p>
         </p:txBody>
       </p:sp>
@@ -7885,7 +8028,7 @@
 </file>
 
 <file path=ppt/slides/slide8.xml><?xml version="1.0" encoding="utf-8"?>
-<p:sld xmlns:a="http://schemas.openxmlformats.org/drawingml/2006/main" xmlns:p="http://schemas.openxmlformats.org/presentationml/2006/main" xmlns:r="http://schemas.openxmlformats.org/officeDocument/2006/relationships">
+<p:sld xmlns:a="http://schemas.openxmlformats.org/drawingml/2006/main" xmlns:r="http://schemas.openxmlformats.org/officeDocument/2006/relationships" xmlns:p="http://schemas.openxmlformats.org/presentationml/2006/main">
   <p:cSld>
     <p:spTree>
       <p:nvGrpSpPr>
@@ -7893,7 +8036,14 @@
         <p:cNvGrpSpPr/>
         <p:nvPr/>
       </p:nvGrpSpPr>
-      <p:grpSpPr/>
+      <p:grpSpPr>
+        <a:xfrm>
+          <a:off x="0" y="0"/>
+          <a:ext cx="0" cy="0"/>
+          <a:chOff x="0" y="0"/>
+          <a:chExt cx="0" cy="0"/>
+        </a:xfrm>
+      </p:grpSpPr>
       <p:sp>
         <p:nvSpPr>
           <p:cNvPr id="2" name="Rectangle 1"/>
@@ -7936,6 +8086,7 @@
           <a:lstStyle/>
           <a:p>
             <a:pPr algn="ctr"/>
+            <a:endParaRPr/>
           </a:p>
         </p:txBody>
       </p:sp>
@@ -8066,6 +8217,7 @@
           <a:lstStyle/>
           <a:p>
             <a:pPr algn="ctr"/>
+            <a:endParaRPr/>
           </a:p>
         </p:txBody>
       </p:sp>
@@ -8218,7 +8370,7 @@
 </file>
 
 <file path=ppt/slides/slide9.xml><?xml version="1.0" encoding="utf-8"?>
-<p:sld xmlns:a="http://schemas.openxmlformats.org/drawingml/2006/main" xmlns:p="http://schemas.openxmlformats.org/presentationml/2006/main" xmlns:r="http://schemas.openxmlformats.org/officeDocument/2006/relationships">
+<p:sld xmlns:a="http://schemas.openxmlformats.org/drawingml/2006/main" xmlns:r="http://schemas.openxmlformats.org/officeDocument/2006/relationships" xmlns:p="http://schemas.openxmlformats.org/presentationml/2006/main">
   <p:cSld>
     <p:spTree>
       <p:nvGrpSpPr>
@@ -8226,7 +8378,14 @@
         <p:cNvGrpSpPr/>
         <p:nvPr/>
       </p:nvGrpSpPr>
-      <p:grpSpPr/>
+      <p:grpSpPr>
+        <a:xfrm>
+          <a:off x="0" y="0"/>
+          <a:ext cx="0" cy="0"/>
+          <a:chOff x="0" y="0"/>
+          <a:chExt cx="0" cy="0"/>
+        </a:xfrm>
+      </p:grpSpPr>
       <p:sp>
         <p:nvSpPr>
           <p:cNvPr id="2" name="Rectangle 1"/>
@@ -8269,6 +8428,7 @@
           <a:lstStyle/>
           <a:p>
             <a:pPr algn="ctr"/>
+            <a:endParaRPr/>
           </a:p>
         </p:txBody>
       </p:sp>
@@ -8399,6 +8559,7 @@
           <a:lstStyle/>
           <a:p>
             <a:pPr algn="ctr"/>
+            <a:endParaRPr/>
           </a:p>
         </p:txBody>
       </p:sp>
@@ -8557,6 +8718,7 @@
           <a:lstStyle/>
           <a:p>
             <a:pPr algn="ctr"/>
+            <a:endParaRPr/>
           </a:p>
         </p:txBody>
       </p:sp>

</xml_diff>